<commit_message>
final touches on networking basics slides
</commit_message>
<xml_diff>
--- a/Intro to Computers/Lesson 02 - Networking Basics/Lesson 2 - Network Basics.pptx
+++ b/Intro to Computers/Lesson 02 - Networking Basics/Lesson 2 - Network Basics.pptx
@@ -913,17 +913,55 @@
           <a:bodyPr/>
           <a:lstStyle/>
           <a:p>
+            <a:pPr marL="158750" indent="0">
+              <a:buNone/>
+            </a:pPr>
             <a:r>
               <a:rPr lang="en-US" dirty="0"/>
-              <a:t>Subnetting allows us to split one larger network into multiple, smaller networks.</a:t>
-            </a:r>
+              <a:t>Given a host address, determine network address</a:t>
+            </a:r>
+          </a:p>
+          <a:p>
+            <a:pPr marL="457200" indent="-298450">
+              <a:buFontTx/>
+              <a:buChar char="-"/>
+            </a:pPr>
+            <a:r>
+              <a:rPr lang="en-US" dirty="0"/>
+              <a:t>Convert to binary</a:t>
+            </a:r>
+          </a:p>
+          <a:p>
+            <a:pPr marL="457200" indent="-298450">
+              <a:buFontTx/>
+              <a:buChar char="-"/>
+            </a:pPr>
+            <a:r>
+              <a:rPr lang="en-US" dirty="0"/>
+              <a:t>Apply network mask</a:t>
+            </a:r>
+          </a:p>
+          <a:p>
+            <a:pPr marL="457200" indent="-298450">
+              <a:buFontTx/>
+              <a:buChar char="-"/>
+            </a:pPr>
+            <a:r>
+              <a:rPr lang="en-US" dirty="0"/>
+              <a:t>Convert to </a:t>
+            </a:r>
+            <a:r>
+              <a:rPr lang="en-US"/>
+              <a:t>dotted decimal</a:t>
+            </a:r>
+            <a:endParaRPr lang="en-US" dirty="0"/>
           </a:p>
         </p:txBody>
       </p:sp>
     </p:spTree>
     <p:extLst>
       <p:ext uri="{BB962C8B-B14F-4D97-AF65-F5344CB8AC3E}">
-        <p14:creationId xmlns:p14="http://schemas.microsoft.com/office/powerpoint/2010/main" val="3696674434"/>
+        <p14:creationId xmlns:p14="http://schemas.microsoft.com/office/powerpoint/2010/main" val="3183531809"/>
       </p:ext>
     </p:extLst>
   </p:cSld>
@@ -960,7 +998,12 @@
             <p:ph type="sldImg"/>
           </p:nvPr>
         </p:nvSpPr>
-        <p:spPr/>
+        <p:spPr>
+          <a:xfrm>
+            <a:off x="381000" y="685800"/>
+            <a:ext cx="6096000" cy="3429000"/>
+          </a:xfrm>
+        </p:spPr>
       </p:sp>
       <p:sp>
         <p:nvSpPr>
@@ -977,14 +1020,17 @@
           <a:bodyPr/>
           <a:lstStyle/>
           <a:p>
-            <a:endParaRPr lang="en-US" dirty="0"/>
+            <a:r>
+              <a:rPr lang="en-US" dirty="0"/>
+              <a:t>Subnetting allows us to split one larger network into multiple, smaller networks.</a:t>
+            </a:r>
           </a:p>
         </p:txBody>
       </p:sp>
     </p:spTree>
     <p:extLst>
       <p:ext uri="{BB962C8B-B14F-4D97-AF65-F5344CB8AC3E}">
-        <p14:creationId xmlns:p14="http://schemas.microsoft.com/office/powerpoint/2010/main" val="1766816439"/>
+        <p14:creationId xmlns:p14="http://schemas.microsoft.com/office/powerpoint/2010/main" val="3696674434"/>
       </p:ext>
     </p:extLst>
   </p:cSld>
@@ -1045,6 +1091,67 @@
     </p:spTree>
     <p:extLst>
       <p:ext uri="{BB962C8B-B14F-4D97-AF65-F5344CB8AC3E}">
+        <p14:creationId xmlns:p14="http://schemas.microsoft.com/office/powerpoint/2010/main" val="1766816439"/>
+      </p:ext>
+    </p:extLst>
+  </p:cSld>
+  <p:clrMapOvr>
+    <a:masterClrMapping/>
+  </p:clrMapOvr>
+</p:notes>
+</file>
+
+<file path=ppt/notesSlides/notesSlide6.xml><?xml version="1.0" encoding="utf-8"?>
+<p:notes xmlns:a="http://schemas.openxmlformats.org/drawingml/2006/main" xmlns:r="http://schemas.openxmlformats.org/officeDocument/2006/relationships" xmlns:p="http://schemas.openxmlformats.org/presentationml/2006/main">
+  <p:cSld>
+    <p:spTree>
+      <p:nvGrpSpPr>
+        <p:cNvPr id="1" name=""/>
+        <p:cNvGrpSpPr/>
+        <p:nvPr/>
+      </p:nvGrpSpPr>
+      <p:grpSpPr>
+        <a:xfrm>
+          <a:off x="0" y="0"/>
+          <a:ext cx="0" cy="0"/>
+          <a:chOff x="0" y="0"/>
+          <a:chExt cx="0" cy="0"/>
+        </a:xfrm>
+      </p:grpSpPr>
+      <p:sp>
+        <p:nvSpPr>
+          <p:cNvPr id="2" name="Slide Image Placeholder 1"/>
+          <p:cNvSpPr>
+            <a:spLocks noGrp="1" noRot="1" noChangeAspect="1"/>
+          </p:cNvSpPr>
+          <p:nvPr>
+            <p:ph type="sldImg"/>
+          </p:nvPr>
+        </p:nvSpPr>
+        <p:spPr/>
+      </p:sp>
+      <p:sp>
+        <p:nvSpPr>
+          <p:cNvPr id="3" name="Notes Placeholder 2"/>
+          <p:cNvSpPr>
+            <a:spLocks noGrp="1"/>
+          </p:cNvSpPr>
+          <p:nvPr>
+            <p:ph type="body" idx="1"/>
+          </p:nvPr>
+        </p:nvSpPr>
+        <p:spPr/>
+        <p:txBody>
+          <a:bodyPr/>
+          <a:lstStyle/>
+          <a:p>
+            <a:endParaRPr lang="en-US" dirty="0"/>
+          </a:p>
+        </p:txBody>
+      </p:sp>
+    </p:spTree>
+    <p:extLst>
+      <p:ext uri="{BB962C8B-B14F-4D97-AF65-F5344CB8AC3E}">
         <p14:creationId xmlns:p14="http://schemas.microsoft.com/office/powerpoint/2010/main" val="1511459655"/>
       </p:ext>
     </p:extLst>
@@ -1055,7 +1162,7 @@
 </p:notes>
 </file>
 
-<file path=ppt/notesSlides/notesSlide6.xml><?xml version="1.0" encoding="utf-8"?>
+<file path=ppt/notesSlides/notesSlide7.xml><?xml version="1.0" encoding="utf-8"?>
 <p:notes xmlns:a="http://schemas.openxmlformats.org/drawingml/2006/main" xmlns:r="http://schemas.openxmlformats.org/officeDocument/2006/relationships" xmlns:p="http://schemas.openxmlformats.org/presentationml/2006/main">
   <p:cSld>
     <p:spTree>
@@ -1172,7 +1279,7 @@
           <a:p>
             <a:fld id="{7A3E0868-4E26-4CDC-8A56-D70E2D8B12FE}" type="datetime3">
               <a:rPr lang="en-US" smtClean="0"/>
-              <a:t>7 April 2026</a:t>
+              <a:t>5 May 2026</a:t>
             </a:fld>
             <a:endParaRPr lang="en-US"/>
           </a:p>
@@ -3749,7 +3856,7 @@
           <a:p>
             <a:fld id="{A7B8021B-6105-4216-96FC-94348F216D0E}" type="datetime3">
               <a:rPr lang="en-US" smtClean="0"/>
-              <a:t>7 April 2026</a:t>
+              <a:t>5 May 2026</a:t>
             </a:fld>
             <a:endParaRPr lang="en-US"/>
           </a:p>
@@ -5447,7 +5554,7 @@
           <a:p>
             <a:fld id="{5D27CFAB-73E6-44A8-B862-B3306344E3F2}" type="datetime3">
               <a:rPr lang="en-US" smtClean="0"/>
-              <a:t>7 April 2026</a:t>
+              <a:t>5 May 2026</a:t>
             </a:fld>
             <a:endParaRPr lang="en-US"/>
           </a:p>
@@ -7238,7 +7345,7 @@
           <a:p>
             <a:fld id="{A9B2E784-A5F5-4301-881B-94AC8DBF9DED}" type="datetime3">
               <a:rPr lang="en-US" smtClean="0"/>
-              <a:t>7 April 2026</a:t>
+              <a:t>5 May 2026</a:t>
             </a:fld>
             <a:endParaRPr lang="en-US"/>
           </a:p>
@@ -7418,7 +7525,7 @@
           <a:p>
             <a:fld id="{18EAB3A5-9E92-4BB9-8F22-9632B4FBEDBA}" type="datetime3">
               <a:rPr lang="en-US" smtClean="0"/>
-              <a:t>7 April 2026</a:t>
+              <a:t>5 May 2026</a:t>
             </a:fld>
             <a:endParaRPr lang="en-US"/>
           </a:p>
@@ -7646,7 +7753,7 @@
           <a:p>
             <a:fld id="{40923810-5FB2-48C9-96CA-1DE2C4773142}" type="datetime3">
               <a:rPr lang="en-US" smtClean="0"/>
-              <a:t>7 April 2026</a:t>
+              <a:t>5 May 2026</a:t>
             </a:fld>
             <a:endParaRPr lang="en-US"/>
           </a:p>
@@ -7937,7 +8044,7 @@
           <a:p>
             <a:fld id="{E50EFF4B-86EB-42FB-93EA-7D8F9CB2466F}" type="datetime3">
               <a:rPr lang="en-US" smtClean="0"/>
-              <a:t>7 April 2026</a:t>
+              <a:t>5 May 2026</a:t>
             </a:fld>
             <a:endParaRPr lang="en-US"/>
           </a:p>
@@ -8550,7 +8657,7 @@
           <a:p>
             <a:fld id="{FB14FC24-E041-45E9-9A72-E5755A86890F}" type="datetime3">
               <a:rPr lang="en-US" smtClean="0"/>
-              <a:t>7 April 2026</a:t>
+              <a:t>5 May 2026</a:t>
             </a:fld>
             <a:endParaRPr lang="en-US"/>
           </a:p>
@@ -9411,7 +9518,7 @@
           <a:p>
             <a:fld id="{98A19125-94A7-4474-858C-FD9C4ABE9DDA}" type="datetime3">
               <a:rPr lang="en-US" smtClean="0"/>
-              <a:t>7 April 2026</a:t>
+              <a:t>5 May 2026</a:t>
             </a:fld>
             <a:endParaRPr lang="en-US"/>
           </a:p>
@@ -10515,7 +10622,7 @@
           <a:p>
             <a:fld id="{3BA0343D-C8D8-43CE-BB79-50DEA219DB07}" type="datetime3">
               <a:rPr lang="en-US" smtClean="0"/>
-              <a:t>7 April 2026</a:t>
+              <a:t>5 May 2026</a:t>
             </a:fld>
             <a:endParaRPr lang="en-US"/>
           </a:p>
@@ -10805,7 +10912,7 @@
           <a:p>
             <a:fld id="{453BD212-0B9F-4987-965F-AC83B2FC354F}" type="datetime3">
               <a:rPr lang="en-US" smtClean="0"/>
-              <a:t>7 April 2026</a:t>
+              <a:t>5 May 2026</a:t>
             </a:fld>
             <a:endParaRPr lang="en-US"/>
           </a:p>
@@ -11049,7 +11156,7 @@
           <a:p>
             <a:fld id="{6DDC931E-8CBE-4A3F-A034-9B6122C6DCDB}" type="datetime3">
               <a:rPr lang="en-US" smtClean="0"/>
-              <a:t>7 April 2026</a:t>
+              <a:t>5 May 2026</a:t>
             </a:fld>
             <a:endParaRPr lang="en-US"/>
           </a:p>
@@ -12832,7 +12939,7 @@
           <a:p>
             <a:fld id="{220AF9C2-5E8A-4308-AE6B-CA9B65007D0E}" type="datetime3">
               <a:rPr lang="en-US" smtClean="0"/>
-              <a:t>7 April 2026</a:t>
+              <a:t>5 May 2026</a:t>
             </a:fld>
             <a:endParaRPr lang="en-US"/>
           </a:p>
@@ -13146,7 +13253,7 @@
           <a:p>
             <a:fld id="{FF31E861-D2AF-431D-860B-DCF67C218052}" type="datetime3">
               <a:rPr lang="en-US" smtClean="0"/>
-              <a:t>7 April 2026</a:t>
+              <a:t>5 May 2026</a:t>
             </a:fld>
             <a:endParaRPr lang="en-US"/>
           </a:p>
@@ -13426,7 +13533,7 @@
           <a:p>
             <a:fld id="{D1DA25B2-AAF1-4C1F-AA38-12D5BFA7D4C8}" type="datetime3">
               <a:rPr lang="en-US" smtClean="0"/>
-              <a:t>7 April 2026</a:t>
+              <a:t>5 May 2026</a:t>
             </a:fld>
             <a:endParaRPr lang="en-US"/>
           </a:p>
@@ -13706,7 +13813,7 @@
           <a:p>
             <a:fld id="{A25C0F39-45D0-48E9-90B3-7FE8FCE561C8}" type="datetime3">
               <a:rPr lang="en-US" smtClean="0"/>
-              <a:t>7 April 2026</a:t>
+              <a:t>5 May 2026</a:t>
             </a:fld>
             <a:endParaRPr lang="en-US"/>
           </a:p>
@@ -14208,7 +14315,7 @@
           <a:p>
             <a:fld id="{9BAF1A3D-92FA-4F24-9781-74AFA516A230}" type="datetime3">
               <a:rPr lang="en-US" smtClean="0"/>
-              <a:t>7 April 2026</a:t>
+              <a:t>5 May 2026</a:t>
             </a:fld>
             <a:endParaRPr lang="en-US"/>
           </a:p>
@@ -14336,7 +14443,7 @@
           <a:p>
             <a:fld id="{5719C672-856D-4617-A693-8FE15749A9B7}" type="datetime3">
               <a:rPr lang="en-US" smtClean="0"/>
-              <a:t>7 April 2026</a:t>
+              <a:t>5 May 2026</a:t>
             </a:fld>
             <a:endParaRPr lang="en-US"/>
           </a:p>
@@ -14472,7 +14579,7 @@
           <a:p>
             <a:fld id="{5F6C764D-A39E-4C03-B161-E0BC66E8883B}" type="datetime3">
               <a:rPr lang="en-US" smtClean="0"/>
-              <a:t>7 April 2026</a:t>
+              <a:t>5 May 2026</a:t>
             </a:fld>
             <a:endParaRPr lang="en-US"/>
           </a:p>
@@ -14711,7 +14818,7 @@
           <a:p>
             <a:fld id="{6E3E33F9-20B7-4995-BE7D-165DBB597850}" type="datetime3">
               <a:rPr lang="en-US" smtClean="0"/>
-              <a:t>7 April 2026</a:t>
+              <a:t>5 May 2026</a:t>
             </a:fld>
             <a:endParaRPr lang="en-US"/>
           </a:p>
@@ -14825,7 +14932,7 @@
           <a:p>
             <a:fld id="{CD41C263-3501-4369-A962-62B6BF915CDE}" type="datetime3">
               <a:rPr lang="en-US" smtClean="0"/>
-              <a:t>7 April 2026</a:t>
+              <a:t>5 May 2026</a:t>
             </a:fld>
             <a:endParaRPr lang="en-US"/>
           </a:p>
@@ -15229,7 +15336,7 @@
           <a:p>
             <a:fld id="{B06F3EBE-B2E8-4992-9F00-9E4B44F057C0}" type="datetime3">
               <a:rPr lang="en-US" smtClean="0"/>
-              <a:t>7 April 2026</a:t>
+              <a:t>5 May 2026</a:t>
             </a:fld>
             <a:endParaRPr lang="en-US"/>
           </a:p>
@@ -15362,7 +15469,7 @@
           <a:p>
             <a:fld id="{D41656AB-D2E1-472E-8B95-0DF5C6E1D623}" type="datetime3">
               <a:rPr lang="en-US" smtClean="0"/>
-              <a:t>7 April 2026</a:t>
+              <a:t>5 May 2026</a:t>
             </a:fld>
             <a:endParaRPr lang="en-US"/>
           </a:p>
@@ -17270,7 +17377,7 @@
           <a:p>
             <a:fld id="{AD622D1A-DF83-41A8-85FF-04D90BF831D3}" type="datetime3">
               <a:rPr lang="en-US" smtClean="0"/>
-              <a:t>7 April 2026</a:t>
+              <a:t>5 May 2026</a:t>
             </a:fld>
             <a:endParaRPr lang="en-US"/>
           </a:p>
@@ -17521,7 +17628,7 @@
           <a:p>
             <a:fld id="{334F72C3-CDF3-44A8-B602-1649B1728485}" type="datetime3">
               <a:rPr lang="en-US" smtClean="0"/>
-              <a:t>7 April 2026</a:t>
+              <a:t>5 May 2026</a:t>
             </a:fld>
             <a:endParaRPr lang="en-US"/>
           </a:p>
@@ -17829,7 +17936,7 @@
           <a:p>
             <a:fld id="{1E0132BA-B5E7-4FFD-AF6C-169169D47D4A}" type="datetime3">
               <a:rPr lang="en-US" smtClean="0"/>
-              <a:t>7 April 2026</a:t>
+              <a:t>5 May 2026</a:t>
             </a:fld>
             <a:endParaRPr lang="en-US"/>
           </a:p>
@@ -18311,7 +18418,7 @@
           <a:p>
             <a:fld id="{81A30091-1C2A-4151-8D3C-D1E47A72615F}" type="datetime3">
               <a:rPr lang="en-US" smtClean="0"/>
-              <a:t>7 April 2026</a:t>
+              <a:t>5 May 2026</a:t>
             </a:fld>
             <a:endParaRPr lang="en-US"/>
           </a:p>
@@ -18949,7 +19056,7 @@
           <a:p>
             <a:fld id="{35D703CE-07B4-4C05-A488-B4566700621F}" type="datetime3">
               <a:rPr lang="en-US" smtClean="0"/>
-              <a:t>7 April 2026</a:t>
+              <a:t>5 May 2026</a:t>
             </a:fld>
             <a:endParaRPr lang="en-US"/>
           </a:p>
@@ -20008,7 +20115,7 @@
           <a:p>
             <a:fld id="{694BD61C-20BA-43AF-A21F-1DAFB3200099}" type="datetime3">
               <a:rPr lang="en-US" smtClean="0"/>
-              <a:t>7 April 2026</a:t>
+              <a:t>5 May 2026</a:t>
             </a:fld>
             <a:endParaRPr lang="en-US"/>
           </a:p>
@@ -20497,7 +20604,7 @@
           <a:p>
             <a:fld id="{CABCB1B0-B6E5-4DD1-BB55-95C076D6C0C8}" type="datetime3">
               <a:rPr lang="en-US" smtClean="0"/>
-              <a:t>7 April 2026</a:t>
+              <a:t>5 May 2026</a:t>
             </a:fld>
             <a:endParaRPr lang="en-US"/>
           </a:p>
@@ -21048,7 +21155,7 @@
           <a:p>
             <a:fld id="{7A3E0868-4E26-4CDC-8A56-D70E2D8B12FE}" type="datetime3">
               <a:rPr lang="en-US" smtClean="0"/>
-              <a:t>7 April 2026</a:t>
+              <a:t>5 May 2026</a:t>
             </a:fld>
             <a:endParaRPr lang="en-US"/>
           </a:p>
@@ -29602,7 +29709,7 @@
             </a:r>
             <a:r>
               <a:rPr lang="en-US" dirty="0"/>
-              <a:t> when they can talk to other devices</a:t>
+              <a:t> when they can talk to other devices (citation needed)</a:t>
             </a:r>
           </a:p>
           <a:p>

</xml_diff>